<commit_message>
it's been a while...
</commit_message>
<xml_diff>
--- a/resources/ppt_Agapiades_28_05_2024_V2.pptx
+++ b/resources/ppt_Agapiades_28_05_2024_V2.pptx
@@ -257,7 +257,7 @@
           <a:p>
             <a:fld id="{7661BBF3-AB93-4E18-A0E7-F987E2EF006B}" type="datetimeFigureOut">
               <a:rPr lang="fr-FR" smtClean="0"/>
-              <a:t>24/05/2024</a:t>
+              <a:t>28/05/2024</a:t>
             </a:fld>
             <a:endParaRPr lang="fr-FR"/>
           </a:p>
@@ -440,7 +440,7 @@
             </a:pPr>
             <a:fld id="{BE0DBB7D-6866-2743-9322-21A38D7516EE}" type="datetimeFigureOut">
               <a:rPr lang="fr-FR"/>
-              <a:t>24/05/2024</a:t>
+              <a:t>28/05/2024</a:t>
             </a:fld>
             <a:endParaRPr lang="fr-FR"/>
           </a:p>
@@ -868,6 +868,102 @@
           <a:bodyPr/>
           <a:lstStyle/>
           <a:p>
+            <a:r>
+              <a:rPr lang="fr-FR" dirty="0"/>
+              <a:t>In </a:t>
+            </a:r>
+            <a:r>
+              <a:rPr lang="fr-FR" dirty="0" err="1"/>
+              <a:t>order</a:t>
+            </a:r>
+            <a:r>
+              <a:rPr lang="fr-FR" dirty="0"/>
+              <a:t> to </a:t>
+            </a:r>
+            <a:r>
+              <a:rPr lang="fr-FR" dirty="0" err="1"/>
+              <a:t>find</a:t>
+            </a:r>
+            <a:r>
+              <a:rPr lang="fr-FR" dirty="0"/>
+              <a:t> the best combinations of plants (</a:t>
+            </a:r>
+            <a:r>
+              <a:rPr lang="fr-FR" dirty="0" err="1"/>
+              <a:t>genotypes</a:t>
+            </a:r>
+            <a:r>
+              <a:rPr lang="fr-FR" dirty="0"/>
+              <a:t>), </a:t>
+            </a:r>
+            <a:r>
+              <a:rPr lang="fr-FR" dirty="0" err="1"/>
+              <a:t>environment</a:t>
+            </a:r>
+            <a:r>
+              <a:rPr lang="fr-FR" dirty="0"/>
+              <a:t> and management, </a:t>
+            </a:r>
+            <a:r>
+              <a:rPr lang="fr-FR" dirty="0" err="1"/>
+              <a:t>models</a:t>
+            </a:r>
+            <a:r>
+              <a:rPr lang="fr-FR" dirty="0"/>
+              <a:t> can </a:t>
+            </a:r>
+            <a:r>
+              <a:rPr lang="fr-FR" dirty="0" err="1"/>
+              <a:t>be</a:t>
+            </a:r>
+            <a:r>
+              <a:rPr lang="fr-FR" dirty="0"/>
+              <a:t> an </a:t>
+            </a:r>
+            <a:r>
+              <a:rPr lang="fr-FR" dirty="0" err="1"/>
+              <a:t>interesting</a:t>
+            </a:r>
+            <a:r>
+              <a:rPr lang="fr-FR" dirty="0"/>
+              <a:t> </a:t>
+            </a:r>
+            <a:r>
+              <a:rPr lang="fr-FR" dirty="0" err="1"/>
+              <a:t>tool</a:t>
+            </a:r>
+            <a:r>
+              <a:rPr lang="fr-FR" dirty="0"/>
+              <a:t>, </a:t>
+            </a:r>
+            <a:r>
+              <a:rPr lang="fr-FR" dirty="0" err="1"/>
+              <a:t>before</a:t>
+            </a:r>
+            <a:r>
+              <a:rPr lang="fr-FR" dirty="0"/>
+              <a:t> </a:t>
+            </a:r>
+            <a:r>
+              <a:rPr lang="fr-FR" dirty="0" err="1"/>
+              <a:t>implementing</a:t>
+            </a:r>
+            <a:r>
+              <a:rPr lang="fr-FR" dirty="0"/>
+              <a:t> </a:t>
+            </a:r>
+            <a:r>
+              <a:rPr lang="fr-FR" dirty="0" err="1"/>
+              <a:t>field</a:t>
+            </a:r>
+            <a:r>
+              <a:rPr lang="fr-FR" dirty="0"/>
+              <a:t> </a:t>
+            </a:r>
+            <a:r>
+              <a:rPr lang="fr-FR" dirty="0" err="1"/>
+              <a:t>experiments</a:t>
+            </a:r>
             <a:endParaRPr lang="en-US" dirty="0"/>
           </a:p>
         </p:txBody>
@@ -956,14 +1052,511 @@
           <a:lstStyle/>
           <a:p>
             <a:r>
+              <a:rPr lang="fr-FR" dirty="0" err="1"/>
+              <a:t>Crop</a:t>
+            </a:r>
+            <a:r>
+              <a:rPr lang="fr-FR" dirty="0"/>
+              <a:t> </a:t>
+            </a:r>
+            <a:r>
+              <a:rPr lang="fr-FR" dirty="0" err="1"/>
+              <a:t>models</a:t>
+            </a:r>
+            <a:r>
+              <a:rPr lang="fr-FR" dirty="0"/>
+              <a:t> </a:t>
+            </a:r>
+            <a:r>
+              <a:rPr lang="fr-FR" dirty="0" err="1"/>
+              <a:t>consider</a:t>
+            </a:r>
+            <a:r>
+              <a:rPr lang="fr-FR" dirty="0"/>
+              <a:t> a 1D </a:t>
+            </a:r>
+            <a:r>
+              <a:rPr lang="fr-FR" dirty="0" err="1"/>
+              <a:t>homogeneous</a:t>
+            </a:r>
+            <a:r>
+              <a:rPr lang="fr-FR" dirty="0"/>
+              <a:t> plot, </a:t>
+            </a:r>
+            <a:r>
+              <a:rPr lang="fr-FR" dirty="0" err="1"/>
+              <a:t>so</a:t>
+            </a:r>
+            <a:r>
+              <a:rPr lang="fr-FR" dirty="0"/>
+              <a:t> the </a:t>
+            </a:r>
+            <a:r>
+              <a:rPr lang="fr-FR" dirty="0" err="1"/>
+              <a:t>only</a:t>
+            </a:r>
+            <a:r>
+              <a:rPr lang="fr-FR" dirty="0"/>
+              <a:t> </a:t>
+            </a:r>
+            <a:r>
+              <a:rPr lang="fr-FR" dirty="0" err="1"/>
+              <a:t>heterogeneity</a:t>
+            </a:r>
+            <a:r>
+              <a:rPr lang="fr-FR" dirty="0"/>
+              <a:t> </a:t>
+            </a:r>
+            <a:r>
+              <a:rPr lang="fr-FR" dirty="0" err="1"/>
+              <a:t>is</a:t>
+            </a:r>
+            <a:r>
+              <a:rPr lang="fr-FR" dirty="0"/>
+              <a:t> vertical, and </a:t>
+            </a:r>
+            <a:r>
+              <a:rPr lang="fr-FR" dirty="0" err="1"/>
+              <a:t>it</a:t>
+            </a:r>
+            <a:r>
+              <a:rPr lang="fr-FR" dirty="0"/>
+              <a:t> </a:t>
+            </a:r>
+            <a:r>
+              <a:rPr lang="fr-FR" dirty="0" err="1"/>
+              <a:t>considers</a:t>
+            </a:r>
+            <a:r>
+              <a:rPr lang="fr-FR" dirty="0"/>
+              <a:t> an </a:t>
+            </a:r>
+            <a:r>
+              <a:rPr lang="fr-FR" dirty="0" err="1"/>
+              <a:t>average</a:t>
+            </a:r>
+            <a:r>
+              <a:rPr lang="fr-FR" dirty="0"/>
+              <a:t> plant for the </a:t>
+            </a:r>
+            <a:r>
+              <a:rPr lang="fr-FR" dirty="0" err="1"/>
+              <a:t>whole</a:t>
+            </a:r>
+            <a:r>
+              <a:rPr lang="fr-FR" dirty="0"/>
+              <a:t> </a:t>
+            </a:r>
+            <a:r>
+              <a:rPr lang="fr-FR" dirty="0" err="1"/>
+              <a:t>crop</a:t>
+            </a:r>
+            <a:r>
+              <a:rPr lang="fr-FR" dirty="0"/>
+              <a:t>. So </a:t>
+            </a:r>
+            <a:r>
+              <a:rPr lang="fr-FR" dirty="0" err="1"/>
+              <a:t>you</a:t>
+            </a:r>
+            <a:r>
+              <a:rPr lang="fr-FR" dirty="0"/>
+              <a:t> </a:t>
+            </a:r>
+            <a:r>
+              <a:rPr lang="fr-FR" dirty="0" err="1"/>
+              <a:t>calibrate</a:t>
+            </a:r>
+            <a:r>
+              <a:rPr lang="fr-FR" dirty="0"/>
+              <a:t> </a:t>
+            </a:r>
+            <a:r>
+              <a:rPr lang="fr-FR" dirty="0" err="1"/>
+              <a:t>your</a:t>
+            </a:r>
+            <a:r>
+              <a:rPr lang="fr-FR" dirty="0"/>
+              <a:t> </a:t>
+            </a:r>
+            <a:r>
+              <a:rPr lang="fr-FR" dirty="0" err="1"/>
+              <a:t>parameters</a:t>
+            </a:r>
+            <a:r>
+              <a:rPr lang="fr-FR" dirty="0"/>
+              <a:t> </a:t>
+            </a:r>
+            <a:r>
+              <a:rPr lang="fr-FR" dirty="0" err="1"/>
+              <a:t>with</a:t>
+            </a:r>
+            <a:r>
+              <a:rPr lang="fr-FR" dirty="0"/>
+              <a:t> </a:t>
+            </a:r>
+            <a:r>
+              <a:rPr lang="fr-FR" dirty="0" err="1"/>
+              <a:t>field</a:t>
+            </a:r>
+            <a:r>
+              <a:rPr lang="fr-FR" dirty="0"/>
+              <a:t> data, and </a:t>
+            </a:r>
+            <a:r>
+              <a:rPr lang="fr-FR" dirty="0" err="1"/>
+              <a:t>then</a:t>
+            </a:r>
+            <a:r>
+              <a:rPr lang="fr-FR" dirty="0"/>
+              <a:t> </a:t>
+            </a:r>
+            <a:r>
+              <a:rPr lang="fr-FR" dirty="0" err="1"/>
+              <a:t>you</a:t>
+            </a:r>
+            <a:r>
+              <a:rPr lang="fr-FR" dirty="0"/>
+              <a:t> can run </a:t>
+            </a:r>
+            <a:r>
+              <a:rPr lang="fr-FR" dirty="0" err="1"/>
+              <a:t>your</a:t>
+            </a:r>
+            <a:r>
+              <a:rPr lang="fr-FR" dirty="0"/>
+              <a:t> model for </a:t>
+            </a:r>
+            <a:r>
+              <a:rPr lang="fr-FR" dirty="0" err="1"/>
+              <a:t>months</a:t>
+            </a:r>
+            <a:r>
+              <a:rPr lang="fr-FR" dirty="0"/>
+              <a:t> to </a:t>
+            </a:r>
+            <a:r>
+              <a:rPr lang="fr-FR" dirty="0" err="1"/>
+              <a:t>years</a:t>
+            </a:r>
+            <a:r>
+              <a:rPr lang="fr-FR" dirty="0"/>
+              <a:t> of simulation on a </a:t>
+            </a:r>
+            <a:r>
+              <a:rPr lang="fr-FR" dirty="0" err="1"/>
+              <a:t>daily</a:t>
+            </a:r>
+            <a:r>
+              <a:rPr lang="fr-FR" dirty="0"/>
+              <a:t> time </a:t>
+            </a:r>
+            <a:r>
+              <a:rPr lang="fr-FR" dirty="0" err="1"/>
+              <a:t>scale</a:t>
+            </a:r>
+            <a:r>
+              <a:rPr lang="fr-FR" dirty="0"/>
+              <a:t>.</a:t>
+            </a:r>
+          </a:p>
+          <a:p>
+            <a:r>
+              <a:rPr lang="fr-FR" dirty="0"/>
+              <a:t>FSPM are </a:t>
+            </a:r>
+            <a:r>
+              <a:rPr lang="fr-FR" dirty="0" err="1"/>
+              <a:t>spatially</a:t>
+            </a:r>
+            <a:r>
+              <a:rPr lang="fr-FR" dirty="0"/>
+              <a:t> explicit, </a:t>
+            </a:r>
+            <a:r>
+              <a:rPr lang="fr-FR" dirty="0" err="1"/>
+              <a:t>which</a:t>
+            </a:r>
+            <a:r>
+              <a:rPr lang="fr-FR" dirty="0"/>
+              <a:t> </a:t>
+            </a:r>
+            <a:r>
+              <a:rPr lang="fr-FR" dirty="0" err="1"/>
+              <a:t>means</a:t>
+            </a:r>
+            <a:r>
+              <a:rPr lang="fr-FR" dirty="0"/>
+              <a:t> </a:t>
+            </a:r>
+            <a:r>
+              <a:rPr lang="fr-FR" dirty="0" err="1"/>
+              <a:t>that</a:t>
+            </a:r>
+            <a:r>
+              <a:rPr lang="fr-FR" dirty="0"/>
+              <a:t> </a:t>
+            </a:r>
+            <a:r>
+              <a:rPr lang="fr-FR" dirty="0" err="1"/>
+              <a:t>they</a:t>
+            </a:r>
+            <a:r>
+              <a:rPr lang="fr-FR" dirty="0"/>
+              <a:t> </a:t>
+            </a:r>
+            <a:r>
+              <a:rPr lang="fr-FR" dirty="0" err="1"/>
+              <a:t>consider</a:t>
+            </a:r>
+            <a:r>
+              <a:rPr lang="fr-FR" dirty="0"/>
+              <a:t> the 3D architecture of the plant and </a:t>
+            </a:r>
+            <a:r>
+              <a:rPr lang="fr-FR" dirty="0" err="1"/>
+              <a:t>operate</a:t>
+            </a:r>
+            <a:r>
+              <a:rPr lang="fr-FR" dirty="0"/>
+              <a:t> at </a:t>
+            </a:r>
+            <a:r>
+              <a:rPr lang="fr-FR" dirty="0" err="1"/>
+              <a:t>organ</a:t>
+            </a:r>
+            <a:r>
+              <a:rPr lang="fr-FR" dirty="0"/>
+              <a:t> </a:t>
+            </a:r>
+            <a:r>
+              <a:rPr lang="fr-FR" dirty="0" err="1"/>
+              <a:t>scale</a:t>
+            </a:r>
+            <a:r>
+              <a:rPr lang="fr-FR" dirty="0"/>
+              <a:t> and at a </a:t>
+            </a:r>
+            <a:r>
+              <a:rPr lang="fr-FR" dirty="0" err="1"/>
+              <a:t>finer</a:t>
+            </a:r>
+            <a:r>
+              <a:rPr lang="fr-FR" dirty="0"/>
+              <a:t> time </a:t>
+            </a:r>
+            <a:r>
+              <a:rPr lang="fr-FR" dirty="0" err="1"/>
+              <a:t>scale</a:t>
+            </a:r>
+            <a:r>
+              <a:rPr lang="fr-FR" dirty="0"/>
+              <a:t>, </a:t>
+            </a:r>
+            <a:r>
+              <a:rPr lang="fr-FR" dirty="0" err="1"/>
+              <a:t>hourly</a:t>
+            </a:r>
+            <a:r>
+              <a:rPr lang="fr-FR" dirty="0"/>
+              <a:t> or </a:t>
+            </a:r>
+            <a:r>
+              <a:rPr lang="fr-FR" dirty="0" err="1"/>
+              <a:t>even</a:t>
+            </a:r>
+            <a:r>
+              <a:rPr lang="fr-FR" dirty="0"/>
+              <a:t> </a:t>
+            </a:r>
+            <a:r>
+              <a:rPr lang="fr-FR" dirty="0" err="1"/>
+              <a:t>less</a:t>
+            </a:r>
+            <a:r>
+              <a:rPr lang="fr-FR" dirty="0"/>
+              <a:t>. At </a:t>
+            </a:r>
+            <a:r>
+              <a:rPr lang="fr-FR" dirty="0" err="1"/>
+              <a:t>that</a:t>
+            </a:r>
+            <a:r>
+              <a:rPr lang="fr-FR" dirty="0"/>
+              <a:t> </a:t>
+            </a:r>
+            <a:r>
+              <a:rPr lang="fr-FR" dirty="0" err="1"/>
+              <a:t>scale</a:t>
+            </a:r>
+            <a:r>
+              <a:rPr lang="fr-FR" dirty="0"/>
+              <a:t> </a:t>
+            </a:r>
+            <a:r>
+              <a:rPr lang="fr-FR" dirty="0" err="1"/>
+              <a:t>it</a:t>
+            </a:r>
+            <a:r>
+              <a:rPr lang="fr-FR" dirty="0"/>
+              <a:t> </a:t>
+            </a:r>
+            <a:r>
+              <a:rPr lang="fr-FR" dirty="0" err="1"/>
+              <a:t>is</a:t>
+            </a:r>
+            <a:r>
+              <a:rPr lang="fr-FR" dirty="0"/>
+              <a:t> possible to </a:t>
+            </a:r>
+            <a:r>
+              <a:rPr lang="fr-FR" dirty="0" err="1"/>
+              <a:t>consider</a:t>
+            </a:r>
+            <a:r>
+              <a:rPr lang="fr-FR" dirty="0"/>
+              <a:t> </a:t>
+            </a:r>
+            <a:r>
+              <a:rPr lang="fr-FR" dirty="0" err="1"/>
+              <a:t>so</a:t>
+            </a:r>
+            <a:r>
+              <a:rPr lang="fr-FR" dirty="0"/>
+              <a:t> </a:t>
+            </a:r>
+            <a:r>
+              <a:rPr lang="fr-FR" dirty="0" err="1"/>
+              <a:t>many</a:t>
+            </a:r>
+            <a:r>
+              <a:rPr lang="fr-FR" dirty="0"/>
+              <a:t> </a:t>
+            </a:r>
+            <a:r>
+              <a:rPr lang="fr-FR" dirty="0" err="1"/>
+              <a:t>details</a:t>
+            </a:r>
+            <a:r>
+              <a:rPr lang="fr-FR" dirty="0"/>
+              <a:t> the </a:t>
+            </a:r>
+            <a:r>
+              <a:rPr lang="fr-FR" dirty="0" err="1"/>
+              <a:t>heterogeneity</a:t>
+            </a:r>
+            <a:r>
+              <a:rPr lang="fr-FR" dirty="0"/>
+              <a:t> of </a:t>
+            </a:r>
+            <a:r>
+              <a:rPr lang="fr-FR" dirty="0" err="1"/>
+              <a:t>resource</a:t>
+            </a:r>
+            <a:r>
+              <a:rPr lang="fr-FR" dirty="0"/>
+              <a:t> </a:t>
+            </a:r>
+            <a:r>
+              <a:rPr lang="fr-FR" dirty="0" err="1"/>
+              <a:t>partitioning</a:t>
+            </a:r>
+            <a:r>
+              <a:rPr lang="fr-FR" dirty="0"/>
+              <a:t>, </a:t>
+            </a:r>
+            <a:r>
+              <a:rPr lang="fr-FR" dirty="0" err="1"/>
+              <a:t>etc</a:t>
+            </a:r>
+            <a:r>
+              <a:rPr lang="fr-FR" dirty="0"/>
+              <a:t>, but </a:t>
+            </a:r>
+            <a:r>
+              <a:rPr lang="fr-FR" dirty="0" err="1"/>
+              <a:t>it</a:t>
+            </a:r>
+            <a:r>
+              <a:rPr lang="fr-FR" dirty="0"/>
+              <a:t> has a </a:t>
+            </a:r>
+            <a:r>
+              <a:rPr lang="fr-FR" dirty="0" err="1"/>
+              <a:t>cost</a:t>
+            </a:r>
+            <a:r>
+              <a:rPr lang="fr-FR" dirty="0"/>
+              <a:t>, a high </a:t>
+            </a:r>
+            <a:r>
+              <a:rPr lang="fr-FR" dirty="0" err="1"/>
+              <a:t>computing</a:t>
+            </a:r>
+            <a:r>
+              <a:rPr lang="fr-FR" dirty="0"/>
+              <a:t> </a:t>
+            </a:r>
+            <a:r>
+              <a:rPr lang="fr-FR" dirty="0" err="1"/>
+              <a:t>cost</a:t>
+            </a:r>
+            <a:r>
+              <a:rPr lang="fr-FR" dirty="0"/>
+              <a:t>, and </a:t>
+            </a:r>
+            <a:r>
+              <a:rPr lang="fr-FR" dirty="0" err="1"/>
+              <a:t>also</a:t>
+            </a:r>
+            <a:r>
+              <a:rPr lang="fr-FR" dirty="0"/>
+              <a:t> </a:t>
+            </a:r>
+            <a:r>
+              <a:rPr lang="fr-FR" dirty="0" err="1"/>
+              <a:t>it</a:t>
+            </a:r>
+            <a:r>
+              <a:rPr lang="fr-FR" dirty="0"/>
+              <a:t> </a:t>
+            </a:r>
+            <a:r>
+              <a:rPr lang="fr-FR" dirty="0" err="1"/>
+              <a:t>is</a:t>
+            </a:r>
+            <a:r>
+              <a:rPr lang="fr-FR" dirty="0"/>
+              <a:t> hard to model all </a:t>
+            </a:r>
+            <a:r>
+              <a:rPr lang="fr-FR" dirty="0" err="1"/>
+              <a:t>processes</a:t>
+            </a:r>
+            <a:r>
+              <a:rPr lang="fr-FR" dirty="0"/>
+              <a:t> on a </a:t>
+            </a:r>
+            <a:r>
+              <a:rPr lang="fr-FR" dirty="0" err="1"/>
+              <a:t>whole</a:t>
+            </a:r>
+            <a:r>
+              <a:rPr lang="fr-FR" dirty="0"/>
+              <a:t> plant cycle.</a:t>
+            </a:r>
+            <a:endParaRPr lang="en-US" dirty="0"/>
+          </a:p>
+          <a:p>
+            <a:r>
               <a:rPr lang="en-US" dirty="0"/>
-              <a:t>Different assumptions </a:t>
+              <a:t>Different assumptions, which imply </a:t>
             </a:r>
             <a:r>
               <a:rPr lang="en-US" dirty="0">
                 <a:sym typeface="Wingdings" panose="05000000000000000000" pitchFamily="2" charset="2"/>
               </a:rPr>
-              <a:t> different formalisms for plant processes  ex</a:t>
+              <a:t>different formalisms for plant processes  ex</a:t>
             </a:r>
             <a:endParaRPr lang="en-US" dirty="0"/>
           </a:p>
@@ -999,6 +1592,843 @@
     <p:extLst>
       <p:ext uri="{BB962C8B-B14F-4D97-AF65-F5344CB8AC3E}">
         <p14:creationId xmlns:p14="http://schemas.microsoft.com/office/powerpoint/2010/main" val="2573710193"/>
+      </p:ext>
+    </p:extLst>
+  </p:cSld>
+  <p:clrMapOvr>
+    <a:masterClrMapping/>
+  </p:clrMapOvr>
+</p:notes>
+</file>
+
+<file path=ppt/notesSlides/notesSlide4.xml><?xml version="1.0" encoding="utf-8"?>
+<p:notes xmlns:a="http://schemas.openxmlformats.org/drawingml/2006/main" xmlns:r="http://schemas.openxmlformats.org/officeDocument/2006/relationships" xmlns:p="http://schemas.openxmlformats.org/presentationml/2006/main">
+  <p:cSld>
+    <p:spTree>
+      <p:nvGrpSpPr>
+        <p:cNvPr id="1" name=""/>
+        <p:cNvGrpSpPr/>
+        <p:nvPr/>
+      </p:nvGrpSpPr>
+      <p:grpSpPr>
+        <a:xfrm>
+          <a:off x="0" y="0"/>
+          <a:ext cx="0" cy="0"/>
+          <a:chOff x="0" y="0"/>
+          <a:chExt cx="0" cy="0"/>
+        </a:xfrm>
+      </p:grpSpPr>
+      <p:sp>
+        <p:nvSpPr>
+          <p:cNvPr id="2" name="Slide Image Placeholder 1"/>
+          <p:cNvSpPr>
+            <a:spLocks noGrp="1" noRot="1" noChangeAspect="1"/>
+          </p:cNvSpPr>
+          <p:nvPr>
+            <p:ph type="sldImg"/>
+          </p:nvPr>
+        </p:nvSpPr>
+        <p:spPr/>
+      </p:sp>
+      <p:sp>
+        <p:nvSpPr>
+          <p:cNvPr id="3" name="Notes Placeholder 2"/>
+          <p:cNvSpPr>
+            <a:spLocks noGrp="1"/>
+          </p:cNvSpPr>
+          <p:nvPr>
+            <p:ph type="body" idx="1"/>
+          </p:nvPr>
+        </p:nvSpPr>
+        <p:spPr/>
+        <p:txBody>
+          <a:bodyPr/>
+          <a:lstStyle/>
+          <a:p>
+            <a:r>
+              <a:rPr lang="fr-FR" dirty="0" err="1"/>
+              <a:t>Crop</a:t>
+            </a:r>
+            <a:r>
+              <a:rPr lang="fr-FR" dirty="0"/>
+              <a:t> model: Beer Lambert </a:t>
+            </a:r>
+            <a:r>
+              <a:rPr lang="fr-FR" dirty="0" err="1"/>
+              <a:t>law</a:t>
+            </a:r>
+            <a:r>
+              <a:rPr lang="fr-FR" dirty="0"/>
+              <a:t> of light extinction in </a:t>
+            </a:r>
+            <a:r>
+              <a:rPr lang="fr-FR" dirty="0" err="1"/>
+              <a:t>homogeneous</a:t>
+            </a:r>
+            <a:r>
+              <a:rPr lang="fr-FR" dirty="0"/>
+              <a:t> </a:t>
+            </a:r>
+            <a:r>
+              <a:rPr lang="fr-FR" dirty="0" err="1"/>
+              <a:t>canopy</a:t>
+            </a:r>
+            <a:r>
+              <a:rPr lang="fr-FR" dirty="0"/>
+              <a:t>, </a:t>
+            </a:r>
+            <a:r>
+              <a:rPr lang="fr-FR" dirty="0" err="1"/>
+              <a:t>that</a:t>
+            </a:r>
+            <a:r>
+              <a:rPr lang="fr-FR" dirty="0"/>
+              <a:t> </a:t>
+            </a:r>
+            <a:r>
+              <a:rPr lang="fr-FR" dirty="0" err="1"/>
+              <a:t>depends</a:t>
+            </a:r>
+            <a:r>
+              <a:rPr lang="fr-FR" dirty="0"/>
+              <a:t> on </a:t>
+            </a:r>
+            <a:r>
+              <a:rPr lang="fr-FR" dirty="0" err="1"/>
+              <a:t>leaf</a:t>
+            </a:r>
+            <a:r>
+              <a:rPr lang="fr-FR" dirty="0"/>
+              <a:t> area index</a:t>
+            </a:r>
+          </a:p>
+          <a:p>
+            <a:r>
+              <a:rPr lang="fr-FR" dirty="0"/>
+              <a:t>FSPM: </a:t>
+            </a:r>
+            <a:r>
+              <a:rPr lang="fr-FR" dirty="0" err="1"/>
+              <a:t>we</a:t>
+            </a:r>
+            <a:r>
+              <a:rPr lang="fr-FR" dirty="0"/>
+              <a:t> can use radiative </a:t>
+            </a:r>
+            <a:r>
+              <a:rPr lang="fr-FR" dirty="0" err="1"/>
+              <a:t>transfer</a:t>
+            </a:r>
+            <a:r>
+              <a:rPr lang="fr-FR" dirty="0"/>
+              <a:t> in light interception </a:t>
+            </a:r>
+            <a:r>
+              <a:rPr lang="fr-FR" dirty="0" err="1"/>
+              <a:t>models</a:t>
+            </a:r>
+            <a:endParaRPr lang="fr-FR" dirty="0"/>
+          </a:p>
+          <a:p>
+            <a:r>
+              <a:rPr lang="fr-FR" dirty="0"/>
+              <a:t>There have been </a:t>
+            </a:r>
+            <a:r>
+              <a:rPr lang="fr-FR" dirty="0" err="1"/>
+              <a:t>some</a:t>
+            </a:r>
+            <a:r>
+              <a:rPr lang="fr-FR" dirty="0"/>
+              <a:t> </a:t>
+            </a:r>
+            <a:r>
+              <a:rPr lang="fr-FR" dirty="0" err="1"/>
+              <a:t>improvements</a:t>
+            </a:r>
+            <a:r>
+              <a:rPr lang="fr-FR" dirty="0"/>
+              <a:t> in </a:t>
+            </a:r>
+            <a:r>
+              <a:rPr lang="fr-FR" dirty="0" err="1"/>
+              <a:t>formalisms</a:t>
+            </a:r>
+            <a:r>
+              <a:rPr lang="fr-FR" dirty="0"/>
+              <a:t> in </a:t>
+            </a:r>
+            <a:r>
+              <a:rPr lang="fr-FR" dirty="0" err="1"/>
+              <a:t>crop</a:t>
+            </a:r>
+            <a:r>
+              <a:rPr lang="fr-FR" dirty="0"/>
+              <a:t> </a:t>
+            </a:r>
+            <a:r>
+              <a:rPr lang="fr-FR" dirty="0" err="1"/>
+              <a:t>models</a:t>
+            </a:r>
+            <a:r>
+              <a:rPr lang="fr-FR" dirty="0"/>
+              <a:t>, more </a:t>
+            </a:r>
+            <a:r>
+              <a:rPr lang="fr-FR" dirty="0" err="1"/>
+              <a:t>adapted</a:t>
+            </a:r>
+            <a:r>
+              <a:rPr lang="fr-FR" dirty="0"/>
+              <a:t> for </a:t>
+            </a:r>
+            <a:r>
+              <a:rPr lang="fr-FR" dirty="0" err="1"/>
+              <a:t>heterogeneous</a:t>
+            </a:r>
+            <a:r>
+              <a:rPr lang="fr-FR" dirty="0"/>
+              <a:t> </a:t>
+            </a:r>
+            <a:r>
+              <a:rPr lang="fr-FR" dirty="0" err="1"/>
+              <a:t>canopies</a:t>
+            </a:r>
+            <a:endParaRPr lang="en-US" dirty="0"/>
+          </a:p>
+        </p:txBody>
+      </p:sp>
+      <p:sp>
+        <p:nvSpPr>
+          <p:cNvPr id="4" name="Slide Number Placeholder 3"/>
+          <p:cNvSpPr>
+            <a:spLocks noGrp="1"/>
+          </p:cNvSpPr>
+          <p:nvPr>
+            <p:ph type="sldNum" sz="quarter" idx="5"/>
+          </p:nvPr>
+        </p:nvSpPr>
+        <p:spPr/>
+        <p:txBody>
+          <a:bodyPr/>
+          <a:lstStyle/>
+          <a:p>
+            <a:pPr>
+              <a:defRPr/>
+            </a:pPr>
+            <a:fld id="{F1B85902-0583-884B-B404-8C735AA99CA9}" type="slidenum">
+              <a:rPr lang="fr-FR" smtClean="0"/>
+              <a:t>4</a:t>
+            </a:fld>
+            <a:endParaRPr lang="fr-FR"/>
+          </a:p>
+        </p:txBody>
+      </p:sp>
+    </p:spTree>
+    <p:extLst>
+      <p:ext uri="{BB962C8B-B14F-4D97-AF65-F5344CB8AC3E}">
+        <p14:creationId xmlns:p14="http://schemas.microsoft.com/office/powerpoint/2010/main" val="2793101850"/>
+      </p:ext>
+    </p:extLst>
+  </p:cSld>
+  <p:clrMapOvr>
+    <a:masterClrMapping/>
+  </p:clrMapOvr>
+</p:notes>
+</file>
+
+<file path=ppt/notesSlides/notesSlide5.xml><?xml version="1.0" encoding="utf-8"?>
+<p:notes xmlns:a="http://schemas.openxmlformats.org/drawingml/2006/main" xmlns:r="http://schemas.openxmlformats.org/officeDocument/2006/relationships" xmlns:p="http://schemas.openxmlformats.org/presentationml/2006/main">
+  <p:cSld>
+    <p:spTree>
+      <p:nvGrpSpPr>
+        <p:cNvPr id="1" name=""/>
+        <p:cNvGrpSpPr/>
+        <p:nvPr/>
+      </p:nvGrpSpPr>
+      <p:grpSpPr>
+        <a:xfrm>
+          <a:off x="0" y="0"/>
+          <a:ext cx="0" cy="0"/>
+          <a:chOff x="0" y="0"/>
+          <a:chExt cx="0" cy="0"/>
+        </a:xfrm>
+      </p:grpSpPr>
+      <p:sp>
+        <p:nvSpPr>
+          <p:cNvPr id="2" name="Slide Image Placeholder 1"/>
+          <p:cNvSpPr>
+            <a:spLocks noGrp="1" noRot="1" noChangeAspect="1"/>
+          </p:cNvSpPr>
+          <p:nvPr>
+            <p:ph type="sldImg"/>
+          </p:nvPr>
+        </p:nvSpPr>
+        <p:spPr/>
+      </p:sp>
+      <p:sp>
+        <p:nvSpPr>
+          <p:cNvPr id="3" name="Notes Placeholder 2"/>
+          <p:cNvSpPr>
+            <a:spLocks noGrp="1"/>
+          </p:cNvSpPr>
+          <p:nvPr>
+            <p:ph type="body" idx="1"/>
+          </p:nvPr>
+        </p:nvSpPr>
+        <p:spPr/>
+        <p:txBody>
+          <a:bodyPr/>
+          <a:lstStyle/>
+          <a:p>
+            <a:r>
+              <a:rPr lang="fr-FR" dirty="0" err="1"/>
+              <a:t>Recent</a:t>
+            </a:r>
+            <a:r>
+              <a:rPr lang="fr-FR" dirty="0"/>
+              <a:t> </a:t>
+            </a:r>
+            <a:r>
+              <a:rPr lang="fr-FR" dirty="0" err="1"/>
+              <a:t>formalism</a:t>
+            </a:r>
+            <a:r>
+              <a:rPr lang="fr-FR" dirty="0"/>
+              <a:t> </a:t>
+            </a:r>
+            <a:r>
+              <a:rPr lang="fr-FR" dirty="0" err="1"/>
+              <a:t>implemented</a:t>
+            </a:r>
+            <a:r>
+              <a:rPr lang="fr-FR" dirty="0"/>
+              <a:t> in STICS </a:t>
+            </a:r>
+            <a:r>
+              <a:rPr lang="fr-FR" dirty="0" err="1"/>
+              <a:t>crop</a:t>
+            </a:r>
+            <a:r>
+              <a:rPr lang="fr-FR" dirty="0"/>
+              <a:t> model, </a:t>
+            </a:r>
+            <a:r>
+              <a:rPr lang="fr-FR" dirty="0" err="1"/>
+              <a:t>using</a:t>
+            </a:r>
+            <a:r>
+              <a:rPr lang="fr-FR" dirty="0"/>
+              <a:t> radiative </a:t>
+            </a:r>
+            <a:r>
+              <a:rPr lang="fr-FR" dirty="0" err="1"/>
+              <a:t>transfer</a:t>
+            </a:r>
+            <a:r>
+              <a:rPr lang="fr-FR" dirty="0"/>
+              <a:t> in 2.5D, </a:t>
+            </a:r>
+            <a:r>
+              <a:rPr lang="fr-FR" dirty="0" err="1"/>
+              <a:t>which</a:t>
+            </a:r>
+            <a:r>
+              <a:rPr lang="fr-FR" dirty="0"/>
+              <a:t> enables to </a:t>
+            </a:r>
+            <a:r>
+              <a:rPr lang="fr-FR" dirty="0" err="1"/>
+              <a:t>roughly</a:t>
+            </a:r>
+            <a:r>
+              <a:rPr lang="fr-FR" dirty="0"/>
+              <a:t> </a:t>
+            </a:r>
+            <a:r>
+              <a:rPr lang="fr-FR" dirty="0" err="1"/>
+              <a:t>account</a:t>
+            </a:r>
+            <a:r>
+              <a:rPr lang="fr-FR" dirty="0"/>
+              <a:t> for plants architectures</a:t>
+            </a:r>
+            <a:endParaRPr lang="en-US" dirty="0"/>
+          </a:p>
+        </p:txBody>
+      </p:sp>
+      <p:sp>
+        <p:nvSpPr>
+          <p:cNvPr id="4" name="Slide Number Placeholder 3"/>
+          <p:cNvSpPr>
+            <a:spLocks noGrp="1"/>
+          </p:cNvSpPr>
+          <p:nvPr>
+            <p:ph type="sldNum" sz="quarter" idx="5"/>
+          </p:nvPr>
+        </p:nvSpPr>
+        <p:spPr/>
+        <p:txBody>
+          <a:bodyPr/>
+          <a:lstStyle/>
+          <a:p>
+            <a:pPr>
+              <a:defRPr/>
+            </a:pPr>
+            <a:fld id="{F1B85902-0583-884B-B404-8C735AA99CA9}" type="slidenum">
+              <a:rPr lang="fr-FR" smtClean="0"/>
+              <a:t>5</a:t>
+            </a:fld>
+            <a:endParaRPr lang="fr-FR"/>
+          </a:p>
+        </p:txBody>
+      </p:sp>
+    </p:spTree>
+    <p:extLst>
+      <p:ext uri="{BB962C8B-B14F-4D97-AF65-F5344CB8AC3E}">
+        <p14:creationId xmlns:p14="http://schemas.microsoft.com/office/powerpoint/2010/main" val="1039760083"/>
+      </p:ext>
+    </p:extLst>
+  </p:cSld>
+  <p:clrMapOvr>
+    <a:masterClrMapping/>
+  </p:clrMapOvr>
+</p:notes>
+</file>
+
+<file path=ppt/notesSlides/notesSlide6.xml><?xml version="1.0" encoding="utf-8"?>
+<p:notes xmlns:a="http://schemas.openxmlformats.org/drawingml/2006/main" xmlns:r="http://schemas.openxmlformats.org/officeDocument/2006/relationships" xmlns:p="http://schemas.openxmlformats.org/presentationml/2006/main">
+  <p:cSld>
+    <p:spTree>
+      <p:nvGrpSpPr>
+        <p:cNvPr id="1" name=""/>
+        <p:cNvGrpSpPr/>
+        <p:nvPr/>
+      </p:nvGrpSpPr>
+      <p:grpSpPr>
+        <a:xfrm>
+          <a:off x="0" y="0"/>
+          <a:ext cx="0" cy="0"/>
+          <a:chOff x="0" y="0"/>
+          <a:chExt cx="0" cy="0"/>
+        </a:xfrm>
+      </p:grpSpPr>
+      <p:sp>
+        <p:nvSpPr>
+          <p:cNvPr id="2" name="Slide Image Placeholder 1"/>
+          <p:cNvSpPr>
+            <a:spLocks noGrp="1" noRot="1" noChangeAspect="1"/>
+          </p:cNvSpPr>
+          <p:nvPr>
+            <p:ph type="sldImg"/>
+          </p:nvPr>
+        </p:nvSpPr>
+        <p:spPr/>
+      </p:sp>
+      <p:sp>
+        <p:nvSpPr>
+          <p:cNvPr id="3" name="Notes Placeholder 2"/>
+          <p:cNvSpPr>
+            <a:spLocks noGrp="1"/>
+          </p:cNvSpPr>
+          <p:nvPr>
+            <p:ph type="body" idx="1"/>
+          </p:nvPr>
+        </p:nvSpPr>
+        <p:spPr/>
+        <p:txBody>
+          <a:bodyPr/>
+          <a:lstStyle/>
+          <a:p>
+            <a:r>
+              <a:rPr lang="fr-FR" dirty="0" err="1"/>
+              <a:t>We</a:t>
+            </a:r>
+            <a:r>
+              <a:rPr lang="fr-FR" dirty="0"/>
+              <a:t> have </a:t>
+            </a:r>
+            <a:r>
+              <a:rPr lang="fr-FR" dirty="0" err="1"/>
+              <a:t>seen</a:t>
+            </a:r>
+            <a:r>
+              <a:rPr lang="fr-FR" dirty="0"/>
+              <a:t> </a:t>
+            </a:r>
+            <a:r>
+              <a:rPr lang="fr-FR" dirty="0" err="1"/>
+              <a:t>that</a:t>
+            </a:r>
+            <a:r>
+              <a:rPr lang="fr-FR" dirty="0"/>
+              <a:t> </a:t>
+            </a:r>
+            <a:r>
+              <a:rPr lang="fr-FR" dirty="0" err="1"/>
+              <a:t>both</a:t>
+            </a:r>
+            <a:r>
+              <a:rPr lang="fr-FR" dirty="0"/>
+              <a:t> types of </a:t>
+            </a:r>
+            <a:r>
+              <a:rPr lang="fr-FR" dirty="0" err="1"/>
+              <a:t>models</a:t>
+            </a:r>
+            <a:r>
+              <a:rPr lang="fr-FR" dirty="0"/>
+              <a:t> </a:t>
+            </a:r>
+            <a:r>
+              <a:rPr lang="fr-FR" dirty="0" err="1"/>
+              <a:t>had</a:t>
+            </a:r>
+            <a:r>
+              <a:rPr lang="fr-FR" dirty="0"/>
+              <a:t> </a:t>
+            </a:r>
+            <a:r>
+              <a:rPr lang="fr-FR" dirty="0" err="1"/>
+              <a:t>their</a:t>
+            </a:r>
+            <a:r>
+              <a:rPr lang="fr-FR" dirty="0"/>
+              <a:t> </a:t>
+            </a:r>
+            <a:r>
+              <a:rPr lang="fr-FR" dirty="0" err="1"/>
+              <a:t>benefits</a:t>
+            </a:r>
+            <a:r>
+              <a:rPr lang="fr-FR" dirty="0"/>
+              <a:t> and drawbacks </a:t>
+            </a:r>
+            <a:r>
+              <a:rPr lang="fr-FR" dirty="0" err="1"/>
+              <a:t>when</a:t>
+            </a:r>
+            <a:r>
+              <a:rPr lang="fr-FR" dirty="0"/>
+              <a:t> </a:t>
+            </a:r>
+            <a:r>
+              <a:rPr lang="fr-FR" dirty="0" err="1"/>
+              <a:t>it</a:t>
+            </a:r>
+            <a:r>
+              <a:rPr lang="fr-FR" dirty="0"/>
+              <a:t> </a:t>
+            </a:r>
+            <a:r>
+              <a:rPr lang="fr-FR" dirty="0" err="1"/>
+              <a:t>comes</a:t>
+            </a:r>
+            <a:r>
+              <a:rPr lang="fr-FR" dirty="0"/>
+              <a:t> to modeling </a:t>
+            </a:r>
+            <a:r>
+              <a:rPr lang="fr-FR" dirty="0" err="1"/>
+              <a:t>intercrops</a:t>
+            </a:r>
+            <a:endParaRPr lang="fr-FR" dirty="0"/>
+          </a:p>
+          <a:p>
+            <a:r>
+              <a:rPr lang="fr-FR" dirty="0"/>
+              <a:t>So </a:t>
+            </a:r>
+            <a:r>
+              <a:rPr lang="fr-FR" dirty="0" err="1"/>
+              <a:t>why</a:t>
+            </a:r>
+            <a:r>
+              <a:rPr lang="fr-FR" dirty="0"/>
+              <a:t> not </a:t>
+            </a:r>
+            <a:r>
+              <a:rPr lang="fr-FR" dirty="0" err="1"/>
+              <a:t>adopting</a:t>
+            </a:r>
+            <a:r>
+              <a:rPr lang="fr-FR" dirty="0"/>
+              <a:t> a </a:t>
+            </a:r>
+            <a:r>
+              <a:rPr lang="fr-FR" dirty="0" err="1"/>
+              <a:t>hybrid</a:t>
+            </a:r>
+            <a:r>
+              <a:rPr lang="fr-FR" dirty="0"/>
+              <a:t> </a:t>
+            </a:r>
+            <a:r>
+              <a:rPr lang="fr-FR" dirty="0" err="1"/>
+              <a:t>approach</a:t>
+            </a:r>
+            <a:r>
+              <a:rPr lang="fr-FR" dirty="0"/>
+              <a:t> to exploit the best of </a:t>
+            </a:r>
+            <a:r>
+              <a:rPr lang="fr-FR" dirty="0" err="1"/>
+              <a:t>each</a:t>
+            </a:r>
+            <a:endParaRPr lang="fr-FR" dirty="0"/>
+          </a:p>
+          <a:p>
+            <a:r>
+              <a:rPr lang="fr-FR" dirty="0"/>
+              <a:t>How in practice ?</a:t>
+            </a:r>
+          </a:p>
+          <a:p>
+            <a:r>
+              <a:rPr lang="fr-FR" dirty="0" err="1"/>
+              <a:t>Well</a:t>
+            </a:r>
+            <a:r>
+              <a:rPr lang="fr-FR" dirty="0"/>
+              <a:t> by </a:t>
+            </a:r>
+            <a:r>
+              <a:rPr lang="fr-FR" dirty="0" err="1"/>
+              <a:t>improving</a:t>
+            </a:r>
+            <a:r>
+              <a:rPr lang="fr-FR" dirty="0"/>
+              <a:t> a </a:t>
+            </a:r>
+            <a:r>
+              <a:rPr lang="fr-FR" dirty="0" err="1"/>
+              <a:t>crop</a:t>
+            </a:r>
+            <a:r>
+              <a:rPr lang="fr-FR" dirty="0"/>
+              <a:t> model </a:t>
+            </a:r>
+            <a:r>
+              <a:rPr lang="fr-FR" dirty="0" err="1"/>
+              <a:t>with</a:t>
+            </a:r>
+            <a:r>
+              <a:rPr lang="fr-FR" dirty="0"/>
+              <a:t> an FSPM, and </a:t>
+            </a:r>
+            <a:r>
+              <a:rPr lang="fr-FR" dirty="0" err="1"/>
+              <a:t>thus</a:t>
+            </a:r>
+            <a:r>
+              <a:rPr lang="fr-FR" dirty="0"/>
+              <a:t> </a:t>
+            </a:r>
+            <a:r>
+              <a:rPr lang="fr-FR" dirty="0" err="1"/>
+              <a:t>adding</a:t>
+            </a:r>
+            <a:r>
+              <a:rPr lang="fr-FR" dirty="0"/>
+              <a:t> </a:t>
+            </a:r>
+            <a:r>
+              <a:rPr lang="fr-FR" dirty="0" err="1"/>
+              <a:t>heterogeneity</a:t>
+            </a:r>
+            <a:r>
+              <a:rPr lang="fr-FR" dirty="0"/>
+              <a:t> to </a:t>
+            </a:r>
+            <a:r>
+              <a:rPr lang="fr-FR" dirty="0" err="1"/>
+              <a:t>crop</a:t>
+            </a:r>
+            <a:r>
+              <a:rPr lang="fr-FR" dirty="0"/>
+              <a:t> model </a:t>
+            </a:r>
+            <a:r>
+              <a:rPr lang="fr-FR" dirty="0" err="1"/>
+              <a:t>when</a:t>
+            </a:r>
+            <a:r>
+              <a:rPr lang="fr-FR" dirty="0"/>
+              <a:t> </a:t>
+            </a:r>
+            <a:r>
+              <a:rPr lang="fr-FR" dirty="0" err="1"/>
+              <a:t>needed</a:t>
+            </a:r>
+            <a:endParaRPr lang="fr-FR" dirty="0"/>
+          </a:p>
+        </p:txBody>
+      </p:sp>
+      <p:sp>
+        <p:nvSpPr>
+          <p:cNvPr id="4" name="Slide Number Placeholder 3"/>
+          <p:cNvSpPr>
+            <a:spLocks noGrp="1"/>
+          </p:cNvSpPr>
+          <p:nvPr>
+            <p:ph type="sldNum" sz="quarter" idx="5"/>
+          </p:nvPr>
+        </p:nvSpPr>
+        <p:spPr/>
+        <p:txBody>
+          <a:bodyPr/>
+          <a:lstStyle/>
+          <a:p>
+            <a:pPr>
+              <a:defRPr/>
+            </a:pPr>
+            <a:fld id="{F1B85902-0583-884B-B404-8C735AA99CA9}" type="slidenum">
+              <a:rPr lang="fr-FR" smtClean="0"/>
+              <a:t>6</a:t>
+            </a:fld>
+            <a:endParaRPr lang="fr-FR"/>
+          </a:p>
+        </p:txBody>
+      </p:sp>
+    </p:spTree>
+    <p:extLst>
+      <p:ext uri="{BB962C8B-B14F-4D97-AF65-F5344CB8AC3E}">
+        <p14:creationId xmlns:p14="http://schemas.microsoft.com/office/powerpoint/2010/main" val="1228631620"/>
+      </p:ext>
+    </p:extLst>
+  </p:cSld>
+  <p:clrMapOvr>
+    <a:masterClrMapping/>
+  </p:clrMapOvr>
+</p:notes>
+</file>
+
+<file path=ppt/notesSlides/notesSlide7.xml><?xml version="1.0" encoding="utf-8"?>
+<p:notes xmlns:a="http://schemas.openxmlformats.org/drawingml/2006/main" xmlns:r="http://schemas.openxmlformats.org/officeDocument/2006/relationships" xmlns:p="http://schemas.openxmlformats.org/presentationml/2006/main">
+  <p:cSld>
+    <p:spTree>
+      <p:nvGrpSpPr>
+        <p:cNvPr id="1" name=""/>
+        <p:cNvGrpSpPr/>
+        <p:nvPr/>
+      </p:nvGrpSpPr>
+      <p:grpSpPr>
+        <a:xfrm>
+          <a:off x="0" y="0"/>
+          <a:ext cx="0" cy="0"/>
+          <a:chOff x="0" y="0"/>
+          <a:chExt cx="0" cy="0"/>
+        </a:xfrm>
+      </p:grpSpPr>
+      <p:sp>
+        <p:nvSpPr>
+          <p:cNvPr id="2" name="Slide Image Placeholder 1"/>
+          <p:cNvSpPr>
+            <a:spLocks noGrp="1" noRot="1" noChangeAspect="1"/>
+          </p:cNvSpPr>
+          <p:nvPr>
+            <p:ph type="sldImg"/>
+          </p:nvPr>
+        </p:nvSpPr>
+        <p:spPr/>
+      </p:sp>
+      <p:sp>
+        <p:nvSpPr>
+          <p:cNvPr id="3" name="Notes Placeholder 2"/>
+          <p:cNvSpPr>
+            <a:spLocks noGrp="1"/>
+          </p:cNvSpPr>
+          <p:nvPr>
+            <p:ph type="body" idx="1"/>
+          </p:nvPr>
+        </p:nvSpPr>
+        <p:spPr/>
+        <p:txBody>
+          <a:bodyPr/>
+          <a:lstStyle/>
+          <a:p>
+            <a:r>
+              <a:rPr lang="fr-FR" dirty="0" err="1"/>
+              <a:t>It’s</a:t>
+            </a:r>
+            <a:r>
+              <a:rPr lang="fr-FR" dirty="0"/>
+              <a:t> like </a:t>
+            </a:r>
+            <a:r>
+              <a:rPr lang="fr-FR" dirty="0" err="1"/>
+              <a:t>having</a:t>
+            </a:r>
+            <a:r>
+              <a:rPr lang="fr-FR" dirty="0"/>
+              <a:t> a </a:t>
+            </a:r>
+            <a:r>
+              <a:rPr lang="fr-FR" dirty="0" err="1"/>
+              <a:t>picture</a:t>
+            </a:r>
+            <a:r>
+              <a:rPr lang="fr-FR" dirty="0"/>
+              <a:t> of </a:t>
+            </a:r>
+            <a:r>
+              <a:rPr lang="fr-FR" dirty="0" err="1"/>
+              <a:t>what</a:t>
+            </a:r>
+            <a:r>
+              <a:rPr lang="fr-FR" dirty="0"/>
+              <a:t> a </a:t>
+            </a:r>
+            <a:r>
+              <a:rPr lang="fr-FR" dirty="0" err="1"/>
+              <a:t>crop</a:t>
+            </a:r>
+            <a:r>
+              <a:rPr lang="fr-FR" dirty="0"/>
+              <a:t> model </a:t>
+            </a:r>
+            <a:r>
+              <a:rPr lang="fr-FR" dirty="0" err="1"/>
+              <a:t>would</a:t>
+            </a:r>
+            <a:r>
+              <a:rPr lang="fr-FR" dirty="0"/>
+              <a:t> look like in 3D</a:t>
+            </a:r>
+            <a:endParaRPr lang="en-US" dirty="0"/>
+          </a:p>
+        </p:txBody>
+      </p:sp>
+      <p:sp>
+        <p:nvSpPr>
+          <p:cNvPr id="4" name="Slide Number Placeholder 3"/>
+          <p:cNvSpPr>
+            <a:spLocks noGrp="1"/>
+          </p:cNvSpPr>
+          <p:nvPr>
+            <p:ph type="sldNum" sz="quarter" idx="5"/>
+          </p:nvPr>
+        </p:nvSpPr>
+        <p:spPr/>
+        <p:txBody>
+          <a:bodyPr/>
+          <a:lstStyle/>
+          <a:p>
+            <a:pPr>
+              <a:defRPr/>
+            </a:pPr>
+            <a:fld id="{F1B85902-0583-884B-B404-8C735AA99CA9}" type="slidenum">
+              <a:rPr lang="fr-FR" smtClean="0"/>
+              <a:t>7</a:t>
+            </a:fld>
+            <a:endParaRPr lang="fr-FR"/>
+          </a:p>
+        </p:txBody>
+      </p:sp>
+    </p:spTree>
+    <p:extLst>
+      <p:ext uri="{BB962C8B-B14F-4D97-AF65-F5344CB8AC3E}">
+        <p14:creationId xmlns:p14="http://schemas.microsoft.com/office/powerpoint/2010/main" val="4015851176"/>
       </p:ext>
     </p:extLst>
   </p:cSld>
@@ -3824,7 +5254,7 @@
           <a:p>
             <a:fld id="{97A056E4-9F21-427B-A776-CA9DBA038487}" type="datetimeFigureOut">
               <a:rPr lang="en-US" smtClean="0"/>
-              <a:t>5/24/2024</a:t>
+              <a:t>5/28/2024</a:t>
             </a:fld>
             <a:endParaRPr lang="en-US"/>
           </a:p>
@@ -4022,7 +5452,7 @@
           <a:p>
             <a:fld id="{97A056E4-9F21-427B-A776-CA9DBA038487}" type="datetimeFigureOut">
               <a:rPr lang="en-US" smtClean="0"/>
-              <a:t>5/24/2024</a:t>
+              <a:t>5/28/2024</a:t>
             </a:fld>
             <a:endParaRPr lang="en-US"/>
           </a:p>
@@ -8158,7 +9588,15 @@
             </a:r>
             <a:r>
               <a:rPr lang="fr-FR" dirty="0"/>
-              <a:t> but </a:t>
+              <a:t> </a:t>
+            </a:r>
+            <a:r>
+              <a:rPr lang="fr-FR" dirty="0" err="1"/>
+              <a:t>while</a:t>
+            </a:r>
+            <a:r>
+              <a:rPr lang="fr-FR" dirty="0"/>
+              <a:t> </a:t>
             </a:r>
             <a:r>
               <a:rPr lang="fr-FR" dirty="0" err="1"/>
@@ -9568,8 +11006,8 @@
         </p:nvSpPr>
         <p:spPr>
           <a:xfrm>
-            <a:off x="623888" y="1603683"/>
-            <a:ext cx="3890339" cy="1013321"/>
+            <a:off x="623889" y="1603683"/>
+            <a:ext cx="3276308" cy="1013321"/>
           </a:xfrm>
           <a:ln w="28575">
             <a:noFill/>
@@ -9596,19 +11034,27 @@
           <a:p>
             <a:r>
               <a:rPr lang="fr-FR" sz="1600" i="1" dirty="0"/>
-              <a:t>Ex: S</a:t>
+              <a:t>ex: S</a:t>
             </a:r>
             <a:r>
               <a:rPr lang="en-US" sz="1600" i="1" dirty="0"/>
-              <a:t>TICS (</a:t>
-            </a:r>
-            <a:r>
-              <a:rPr lang="en-US" sz="1600" i="1" dirty="0" err="1"/>
+              <a:t>TICS </a:t>
+            </a:r>
+            <a:r>
+              <a:rPr lang="en-US" sz="1400" i="1" dirty="0"/>
+              <a:t>(</a:t>
+            </a:r>
+            <a:r>
+              <a:rPr lang="en-US" sz="1400" i="1" dirty="0" err="1"/>
               <a:t>Vezy</a:t>
             </a:r>
             <a:r>
+              <a:rPr lang="en-US" sz="1400" i="1" dirty="0"/>
+              <a:t> et al., 2023)</a:t>
+            </a:r>
+            <a:r>
               <a:rPr lang="en-US" sz="1600" i="1" dirty="0"/>
-              <a:t> et al., 2023), </a:t>
+              <a:t>, </a:t>
             </a:r>
             <a:r>
               <a:rPr lang="fr-FR" sz="1600" i="1" dirty="0"/>
@@ -9616,7 +11062,23 @@
             </a:r>
             <a:r>
               <a:rPr lang="en-US" sz="1600" i="1" dirty="0"/>
-              <a:t>PSIM</a:t>
+              <a:t>PSIM </a:t>
+            </a:r>
+            <a:r>
+              <a:rPr lang="en-US" sz="1400" i="1" dirty="0"/>
+              <a:t>(</a:t>
+            </a:r>
+            <a:r>
+              <a:rPr lang="fr-FR" sz="1400" i="1" dirty="0" err="1"/>
+              <a:t>Chimonyo</a:t>
+            </a:r>
+            <a:r>
+              <a:rPr lang="fr-FR" sz="1400" i="1" dirty="0"/>
+              <a:t> et al., 2016</a:t>
+            </a:r>
+            <a:r>
+              <a:rPr lang="en-US" sz="1400" i="1" dirty="0"/>
+              <a:t>)</a:t>
             </a:r>
           </a:p>
           <a:p>
@@ -9642,8 +11104,8 @@
         </p:nvSpPr>
         <p:spPr>
           <a:xfrm>
-            <a:off x="8128216" y="1603682"/>
-            <a:ext cx="3328217" cy="1691657"/>
+            <a:off x="7844174" y="1614166"/>
+            <a:ext cx="3833321" cy="1691657"/>
           </a:xfrm>
           <a:ln w="28575">
             <a:noFill/>
@@ -9677,30 +11139,50 @@
             <a:pPr algn="r"/>
             <a:r>
               <a:rPr lang="fr-FR" sz="1600" i="1" dirty="0"/>
-              <a:t>Ex: V</a:t>
+              <a:t>ex: V</a:t>
             </a:r>
             <a:r>
               <a:rPr lang="en-US" sz="1600" i="1" dirty="0" err="1"/>
-              <a:t>irtualGrassLand</a:t>
+              <a:t>irtual</a:t>
             </a:r>
             <a:r>
               <a:rPr lang="en-US" sz="1600" i="1" dirty="0"/>
-              <a:t> (</a:t>
+              <a:t> </a:t>
             </a:r>
             <a:r>
               <a:rPr lang="en-US" sz="1600" i="1" dirty="0" err="1"/>
+              <a:t>GrassLand</a:t>
+            </a:r>
+            <a:r>
+              <a:rPr lang="en-US" sz="1600" i="1" dirty="0"/>
+              <a:t> </a:t>
+            </a:r>
+            <a:r>
+              <a:rPr lang="en-US" sz="1400" i="1" dirty="0"/>
+              <a:t>(</a:t>
+            </a:r>
+            <a:r>
+              <a:rPr lang="en-US" sz="1400" i="1" dirty="0" err="1"/>
               <a:t>Louarn</a:t>
             </a:r>
             <a:r>
+              <a:rPr lang="en-US" sz="1400" i="1" dirty="0"/>
+              <a:t> et al., 2020), </a:t>
+            </a:r>
+            <a:r>
               <a:rPr lang="en-US" sz="1600" i="1" dirty="0"/>
-              <a:t> et al., 2020), SIMBAL (</a:t>
-            </a:r>
-            <a:r>
-              <a:rPr lang="en-US" sz="1600" i="1" dirty="0" err="1"/>
+              <a:t>SIMBAL </a:t>
+            </a:r>
+            <a:r>
+              <a:rPr lang="en-US" sz="1400" i="1" dirty="0"/>
+              <a:t>(</a:t>
+            </a:r>
+            <a:r>
+              <a:rPr lang="en-US" sz="1400" i="1" dirty="0" err="1"/>
               <a:t>Perthame</a:t>
             </a:r>
             <a:r>
-              <a:rPr lang="en-US" sz="1600" i="1" dirty="0"/>
+              <a:rPr lang="en-US" sz="1400" i="1" dirty="0"/>
               <a:t> et al., 2023)</a:t>
             </a:r>
           </a:p>
@@ -9793,7 +11275,7 @@
         </p:nvSpPr>
         <p:spPr>
           <a:xfrm>
-            <a:off x="6146923" y="1603683"/>
+            <a:off x="5922980" y="1603683"/>
             <a:ext cx="1922753" cy="1844608"/>
           </a:xfrm>
           <a:prstGeom prst="rect">
@@ -9933,7 +11415,29 @@
                 <a:cs typeface="Arial"/>
                 <a:sym typeface="Wingdings" panose="05000000000000000000" pitchFamily="2" charset="2"/>
               </a:rPr>
-              <a:t> of ressource </a:t>
+              <a:t> of </a:t>
+            </a:r>
+            <a:r>
+              <a:rPr lang="fr-FR" dirty="0" err="1">
+                <a:solidFill>
+                  <a:schemeClr val="accent5"/>
+                </a:solidFill>
+                <a:latin typeface="Arial"/>
+                <a:cs typeface="Arial"/>
+                <a:sym typeface="Wingdings" panose="05000000000000000000" pitchFamily="2" charset="2"/>
+              </a:rPr>
+              <a:t>resource</a:t>
+            </a:r>
+            <a:r>
+              <a:rPr lang="fr-FR" dirty="0">
+                <a:solidFill>
+                  <a:schemeClr val="accent5"/>
+                </a:solidFill>
+                <a:latin typeface="Arial"/>
+                <a:cs typeface="Arial"/>
+                <a:sym typeface="Wingdings" panose="05000000000000000000" pitchFamily="2" charset="2"/>
+              </a:rPr>
+              <a:t> </a:t>
             </a:r>
             <a:r>
               <a:rPr lang="fr-FR" dirty="0" err="1">
@@ -11256,7 +12760,7 @@
           <p:nvPr/>
         </p:nvPicPr>
         <p:blipFill>
-          <a:blip r:embed="rId2">
+          <a:blip r:embed="rId3">
             <a:clrChange>
               <a:clrFrom>
                 <a:srgbClr val="FFFFFF"/>
@@ -11507,7 +13011,7 @@
         </p:nvSpPr>
         <p:spPr>
           <a:xfrm>
-            <a:off x="2549517" y="2819508"/>
+            <a:off x="2642117" y="2819508"/>
             <a:ext cx="2498689" cy="369332"/>
           </a:xfrm>
           <a:prstGeom prst="rect">
@@ -11528,7 +13032,7 @@
                 </a:solidFill>
                 <a:latin typeface="Arial"/>
               </a:rPr>
-              <a:t>1D homogeneous plot</a:t>
+              <a:t>homogeneous canopy</a:t>
             </a:r>
             <a:endParaRPr lang="en-US" dirty="0"/>
           </a:p>
@@ -11728,8 +13232,8 @@
           </a:p>
         </p:txBody>
       </p:sp>
-      <mc:AlternateContent xmlns:mc="http://schemas.openxmlformats.org/markup-compatibility/2006">
-        <mc:Choice xmlns:a14="http://schemas.microsoft.com/office/drawing/2010/main" Requires="a14">
+      <mc:AlternateContent xmlns:mc="http://schemas.openxmlformats.org/markup-compatibility/2006" xmlns:a14="http://schemas.microsoft.com/office/drawing/2010/main">
+        <mc:Choice Requires="a14">
           <p:sp>
             <p:nvSpPr>
               <p:cNvPr id="33" name="TextBox 32">
@@ -11758,6 +13262,7 @@
               </a:bodyPr>
               <a:lstStyle/>
               <a:p>
+                <a:pPr/>
                 <a14:m>
                   <m:oMathPara xmlns:m="http://schemas.openxmlformats.org/officeDocument/2006/math">
                     <m:oMathParaPr>
@@ -11834,7 +13339,7 @@
             </p:txBody>
           </p:sp>
         </mc:Choice>
-        <mc:Fallback>
+        <mc:Fallback xmlns="">
           <p:sp>
             <p:nvSpPr>
               <p:cNvPr id="33" name="TextBox 32">
@@ -11858,7 +13363,7 @@
                 <a:avLst/>
               </a:prstGeom>
               <a:blipFill>
-                <a:blip r:embed="rId3"/>
+                <a:blip r:embed="rId4"/>
                 <a:stretch>
                   <a:fillRect b="-14754"/>
                 </a:stretch>
@@ -11948,7 +13453,7 @@
           <p:nvPr/>
         </p:nvPicPr>
         <p:blipFill rotWithShape="1">
-          <a:blip r:embed="rId4">
+          <a:blip r:embed="rId5">
             <a:clrChange>
               <a:clrFrom>
                 <a:srgbClr val="FFFFFF"/>
@@ -11988,7 +13493,7 @@
           <p:nvPr/>
         </p:nvPicPr>
         <p:blipFill rotWithShape="1">
-          <a:blip r:embed="rId4"/>
+          <a:blip r:embed="rId5"/>
           <a:srcRect t="28068" r="80231"/>
           <a:stretch/>
         </p:blipFill>
@@ -12128,8 +13633,8 @@
         </p:nvSpPr>
         <p:spPr>
           <a:xfrm>
-            <a:off x="2227292" y="6265533"/>
-            <a:ext cx="2146217" cy="276999"/>
+            <a:off x="962490" y="6300927"/>
+            <a:ext cx="3928187" cy="276999"/>
           </a:xfrm>
           <a:prstGeom prst="rect">
             <a:avLst/>
@@ -12167,8 +13672,63 @@
                 </a:solidFill>
                 <a:latin typeface="Arial"/>
               </a:rPr>
-              <a:t> et al., 2011)</a:t>
-            </a:r>
+              <a:t> et al., 2011; Ponce de León and Bailey, 2019)</a:t>
+            </a:r>
+          </a:p>
+        </p:txBody>
+      </p:sp>
+      <p:sp>
+        <p:nvSpPr>
+          <p:cNvPr id="2" name="TextBox 1">
+            <a:extLst>
+              <a:ext uri="{FF2B5EF4-FFF2-40B4-BE49-F238E27FC236}">
+                <a16:creationId xmlns:a16="http://schemas.microsoft.com/office/drawing/2014/main" id="{933286D8-70F5-4021-A94C-081BF4B5F44B}"/>
+              </a:ext>
+            </a:extLst>
+          </p:cNvPr>
+          <p:cNvSpPr txBox="1"/>
+          <p:nvPr/>
+        </p:nvSpPr>
+        <p:spPr>
+          <a:xfrm>
+            <a:off x="5882832" y="4155311"/>
+            <a:ext cx="2097568" cy="369332"/>
+          </a:xfrm>
+          <a:prstGeom prst="rect">
+            <a:avLst/>
+          </a:prstGeom>
+          <a:noFill/>
+        </p:spPr>
+        <p:txBody>
+          <a:bodyPr wrap="square" rtlCol="0">
+            <a:spAutoFit/>
+          </a:bodyPr>
+          <a:lstStyle/>
+          <a:p>
+            <a:r>
+              <a:rPr lang="fr-FR" dirty="0">
+                <a:solidFill>
+                  <a:schemeClr val="accent5"/>
+                </a:solidFill>
+                <a:latin typeface="Arial"/>
+              </a:rPr>
+              <a:t>Radiative </a:t>
+            </a:r>
+            <a:r>
+              <a:rPr lang="fr-FR" dirty="0" err="1">
+                <a:solidFill>
+                  <a:schemeClr val="accent5"/>
+                </a:solidFill>
+                <a:latin typeface="Arial"/>
+              </a:rPr>
+              <a:t>transfer</a:t>
+            </a:r>
+            <a:endParaRPr lang="en-US" dirty="0">
+              <a:solidFill>
+                <a:schemeClr val="accent5"/>
+              </a:solidFill>
+              <a:latin typeface="Arial"/>
+            </a:endParaRPr>
           </a:p>
         </p:txBody>
       </p:sp>
@@ -12687,7 +14247,7 @@
           <p:nvPr/>
         </p:nvPicPr>
         <p:blipFill>
-          <a:blip r:embed="rId2"/>
+          <a:blip r:embed="rId3"/>
           <a:stretch>
             <a:fillRect/>
           </a:stretch>
@@ -12717,7 +14277,7 @@
           <p:nvPr/>
         </p:nvPicPr>
         <p:blipFill>
-          <a:blip r:embed="rId3"/>
+          <a:blip r:embed="rId4"/>
           <a:stretch>
             <a:fillRect/>
           </a:stretch>
@@ -12859,7 +14419,7 @@
           <p:nvPr/>
         </p:nvPicPr>
         <p:blipFill>
-          <a:blip r:embed="rId4">
+          <a:blip r:embed="rId5">
             <a:clrChange>
               <a:clrFrom>
                 <a:srgbClr val="FFFFFF"/>
@@ -12986,7 +14546,7 @@
           <p:nvPr/>
         </p:nvPicPr>
         <p:blipFill rotWithShape="1">
-          <a:blip r:embed="rId5">
+          <a:blip r:embed="rId6">
             <a:clrChange>
               <a:clrFrom>
                 <a:srgbClr val="FFFFFF"/>
@@ -13026,7 +14586,7 @@
           <p:nvPr/>
         </p:nvPicPr>
         <p:blipFill rotWithShape="1">
-          <a:blip r:embed="rId5"/>
+          <a:blip r:embed="rId6"/>
           <a:srcRect t="28068" r="80231"/>
           <a:stretch/>
         </p:blipFill>
@@ -13234,7 +14794,7 @@
         </p:nvSpPr>
         <p:spPr>
           <a:xfrm>
-            <a:off x="6400800" y="1707993"/>
+            <a:off x="6366076" y="1806602"/>
             <a:ext cx="3328217" cy="1210538"/>
           </a:xfrm>
           <a:ln w="28575">
@@ -13630,7 +15190,7 @@
         <p:spPr>
           <a:xfrm>
             <a:off x="224202" y="6404032"/>
-            <a:ext cx="2146217" cy="276999"/>
+            <a:ext cx="3330761" cy="276999"/>
           </a:xfrm>
           <a:prstGeom prst="rect">
             <a:avLst/>
@@ -13650,7 +15210,7 @@
                 </a:solidFill>
                 <a:latin typeface="Arial"/>
               </a:rPr>
-              <a:t>(</a:t>
+              <a:t>(Evers et al., 2019; </a:t>
             </a:r>
             <a:r>
               <a:rPr lang="en-US" sz="1200" dirty="0" err="1">
@@ -13963,8 +15523,8 @@
         </p:nvSpPr>
         <p:spPr>
           <a:xfrm>
-            <a:off x="2246265" y="2111987"/>
-            <a:ext cx="8863694" cy="3346981"/>
+            <a:off x="3686276" y="2093837"/>
+            <a:ext cx="5978586" cy="3346981"/>
           </a:xfrm>
         </p:spPr>
         <p:txBody>
@@ -14014,18 +15574,11 @@
             </a:r>
             <a:r>
               <a:rPr lang="en-US" b="1" dirty="0"/>
-              <a:t>structural and spatial aspects</a:t>
+              <a:t>structural and spatial </a:t>
             </a:r>
             <a:r>
               <a:rPr lang="en-US" dirty="0"/>
-              <a:t> </a:t>
-            </a:r>
-          </a:p>
-          <a:p>
-            <a:pPr algn="ctr"/>
-            <a:r>
-              <a:rPr lang="en-US" dirty="0"/>
-              <a:t>adds </a:t>
+              <a:t>aspects adds </a:t>
             </a:r>
             <a:r>
               <a:rPr lang="en-US" b="1" dirty="0"/>
@@ -14061,7 +15614,7 @@
           <p:nvPr/>
         </p:nvPicPr>
         <p:blipFill>
-          <a:blip r:embed="rId2">
+          <a:blip r:embed="rId3">
             <a:clrChange>
               <a:clrFrom>
                 <a:srgbClr val="FFFFFF"/>
@@ -14102,7 +15655,7 @@
           <p:nvPr/>
         </p:nvPicPr>
         <p:blipFill>
-          <a:blip r:embed="rId3">
+          <a:blip r:embed="rId4">
             <a:clrChange>
               <a:clrFrom>
                 <a:srgbClr val="FFFFFF"/>
@@ -14608,6 +16161,577 @@
   <p:clrMapOvr>
     <a:masterClrMapping/>
   </p:clrMapOvr>
+  <p:timing>
+    <p:tnLst>
+      <p:par>
+        <p:cTn id="1" dur="indefinite" restart="never" nodeType="tmRoot">
+          <p:childTnLst>
+            <p:seq concurrent="1" nextAc="seek">
+              <p:cTn id="2" dur="indefinite" nodeType="mainSeq">
+                <p:childTnLst>
+                  <p:par>
+                    <p:cTn id="3" fill="hold">
+                      <p:stCondLst>
+                        <p:cond delay="indefinite"/>
+                      </p:stCondLst>
+                      <p:childTnLst>
+                        <p:par>
+                          <p:cTn id="4" fill="hold">
+                            <p:stCondLst>
+                              <p:cond delay="0"/>
+                            </p:stCondLst>
+                            <p:childTnLst>
+                              <p:par>
+                                <p:cTn id="5" presetID="1" presetClass="entr" presetSubtype="0" fill="hold" grpId="0" nodeType="clickEffect">
+                                  <p:stCondLst>
+                                    <p:cond delay="0"/>
+                                  </p:stCondLst>
+                                  <p:childTnLst>
+                                    <p:set>
+                                      <p:cBhvr>
+                                        <p:cTn id="6" dur="1" fill="hold">
+                                          <p:stCondLst>
+                                            <p:cond delay="0"/>
+                                          </p:stCondLst>
+                                        </p:cTn>
+                                        <p:tgtEl>
+                                          <p:spTgt spid="9">
+                                            <p:txEl>
+                                              <p:pRg st="0" end="0"/>
+                                            </p:txEl>
+                                          </p:spTgt>
+                                        </p:tgtEl>
+                                        <p:attrNameLst>
+                                          <p:attrName>style.visibility</p:attrName>
+                                        </p:attrNameLst>
+                                      </p:cBhvr>
+                                      <p:to>
+                                        <p:strVal val="visible"/>
+                                      </p:to>
+                                    </p:set>
+                                  </p:childTnLst>
+                                </p:cTn>
+                              </p:par>
+                            </p:childTnLst>
+                          </p:cTn>
+                        </p:par>
+                      </p:childTnLst>
+                    </p:cTn>
+                  </p:par>
+                  <p:par>
+                    <p:cTn id="7" fill="hold">
+                      <p:stCondLst>
+                        <p:cond delay="indefinite"/>
+                      </p:stCondLst>
+                      <p:childTnLst>
+                        <p:par>
+                          <p:cTn id="8" fill="hold">
+                            <p:stCondLst>
+                              <p:cond delay="0"/>
+                            </p:stCondLst>
+                            <p:childTnLst>
+                              <p:par>
+                                <p:cTn id="9" presetID="1" presetClass="entr" presetSubtype="0" fill="hold" nodeType="clickEffect">
+                                  <p:stCondLst>
+                                    <p:cond delay="0"/>
+                                  </p:stCondLst>
+                                  <p:childTnLst>
+                                    <p:set>
+                                      <p:cBhvr>
+                                        <p:cTn id="10" dur="1" fill="hold">
+                                          <p:stCondLst>
+                                            <p:cond delay="0"/>
+                                          </p:stCondLst>
+                                        </p:cTn>
+                                        <p:tgtEl>
+                                          <p:spTgt spid="25"/>
+                                        </p:tgtEl>
+                                        <p:attrNameLst>
+                                          <p:attrName>style.visibility</p:attrName>
+                                        </p:attrNameLst>
+                                      </p:cBhvr>
+                                      <p:to>
+                                        <p:strVal val="visible"/>
+                                      </p:to>
+                                    </p:set>
+                                  </p:childTnLst>
+                                </p:cTn>
+                              </p:par>
+                            </p:childTnLst>
+                          </p:cTn>
+                        </p:par>
+                      </p:childTnLst>
+                    </p:cTn>
+                  </p:par>
+                  <p:par>
+                    <p:cTn id="11" fill="hold">
+                      <p:stCondLst>
+                        <p:cond delay="indefinite"/>
+                      </p:stCondLst>
+                      <p:childTnLst>
+                        <p:par>
+                          <p:cTn id="12" fill="hold">
+                            <p:stCondLst>
+                              <p:cond delay="0"/>
+                            </p:stCondLst>
+                            <p:childTnLst>
+                              <p:par>
+                                <p:cTn id="13" presetID="1" presetClass="entr" presetSubtype="0" fill="hold" nodeType="clickEffect">
+                                  <p:stCondLst>
+                                    <p:cond delay="0"/>
+                                  </p:stCondLst>
+                                  <p:childTnLst>
+                                    <p:set>
+                                      <p:cBhvr>
+                                        <p:cTn id="14" dur="1" fill="hold">
+                                          <p:stCondLst>
+                                            <p:cond delay="0"/>
+                                          </p:stCondLst>
+                                        </p:cTn>
+                                        <p:tgtEl>
+                                          <p:spTgt spid="43"/>
+                                        </p:tgtEl>
+                                        <p:attrNameLst>
+                                          <p:attrName>style.visibility</p:attrName>
+                                        </p:attrNameLst>
+                                      </p:cBhvr>
+                                      <p:to>
+                                        <p:strVal val="visible"/>
+                                      </p:to>
+                                    </p:set>
+                                  </p:childTnLst>
+                                </p:cTn>
+                              </p:par>
+                            </p:childTnLst>
+                          </p:cTn>
+                        </p:par>
+                      </p:childTnLst>
+                    </p:cTn>
+                  </p:par>
+                  <p:par>
+                    <p:cTn id="15" fill="hold">
+                      <p:stCondLst>
+                        <p:cond delay="indefinite"/>
+                      </p:stCondLst>
+                      <p:childTnLst>
+                        <p:par>
+                          <p:cTn id="16" fill="hold">
+                            <p:stCondLst>
+                              <p:cond delay="0"/>
+                            </p:stCondLst>
+                            <p:childTnLst>
+                              <p:par>
+                                <p:cTn id="17" presetID="1" presetClass="entr" presetSubtype="0" fill="hold" grpId="0" nodeType="clickEffect">
+                                  <p:stCondLst>
+                                    <p:cond delay="0"/>
+                                  </p:stCondLst>
+                                  <p:childTnLst>
+                                    <p:set>
+                                      <p:cBhvr>
+                                        <p:cTn id="18" dur="1" fill="hold">
+                                          <p:stCondLst>
+                                            <p:cond delay="0"/>
+                                          </p:stCondLst>
+                                        </p:cTn>
+                                        <p:tgtEl>
+                                          <p:spTgt spid="9">
+                                            <p:txEl>
+                                              <p:pRg st="3" end="3"/>
+                                            </p:txEl>
+                                          </p:spTgt>
+                                        </p:tgtEl>
+                                        <p:attrNameLst>
+                                          <p:attrName>style.visibility</p:attrName>
+                                        </p:attrNameLst>
+                                      </p:cBhvr>
+                                      <p:to>
+                                        <p:strVal val="visible"/>
+                                      </p:to>
+                                    </p:set>
+                                  </p:childTnLst>
+                                </p:cTn>
+                              </p:par>
+                            </p:childTnLst>
+                          </p:cTn>
+                        </p:par>
+                      </p:childTnLst>
+                    </p:cTn>
+                  </p:par>
+                  <p:par>
+                    <p:cTn id="19" fill="hold">
+                      <p:stCondLst>
+                        <p:cond delay="indefinite"/>
+                      </p:stCondLst>
+                      <p:childTnLst>
+                        <p:par>
+                          <p:cTn id="20" fill="hold">
+                            <p:stCondLst>
+                              <p:cond delay="0"/>
+                            </p:stCondLst>
+                            <p:childTnLst>
+                              <p:par>
+                                <p:cTn id="21" presetID="1" presetClass="entr" presetSubtype="0" fill="hold" nodeType="clickEffect">
+                                  <p:stCondLst>
+                                    <p:cond delay="0"/>
+                                  </p:stCondLst>
+                                  <p:childTnLst>
+                                    <p:set>
+                                      <p:cBhvr>
+                                        <p:cTn id="22" dur="1" fill="hold">
+                                          <p:stCondLst>
+                                            <p:cond delay="0"/>
+                                          </p:stCondLst>
+                                        </p:cTn>
+                                        <p:tgtEl>
+                                          <p:spTgt spid="44"/>
+                                        </p:tgtEl>
+                                        <p:attrNameLst>
+                                          <p:attrName>style.visibility</p:attrName>
+                                        </p:attrNameLst>
+                                      </p:cBhvr>
+                                      <p:to>
+                                        <p:strVal val="visible"/>
+                                      </p:to>
+                                    </p:set>
+                                  </p:childTnLst>
+                                </p:cTn>
+                              </p:par>
+                            </p:childTnLst>
+                          </p:cTn>
+                        </p:par>
+                      </p:childTnLst>
+                    </p:cTn>
+                  </p:par>
+                  <p:par>
+                    <p:cTn id="23" fill="hold">
+                      <p:stCondLst>
+                        <p:cond delay="indefinite"/>
+                      </p:stCondLst>
+                      <p:childTnLst>
+                        <p:par>
+                          <p:cTn id="24" fill="hold">
+                            <p:stCondLst>
+                              <p:cond delay="0"/>
+                            </p:stCondLst>
+                            <p:childTnLst>
+                              <p:par>
+                                <p:cTn id="25" presetID="1" presetClass="entr" presetSubtype="0" fill="hold" grpId="0" nodeType="clickEffect">
+                                  <p:stCondLst>
+                                    <p:cond delay="0"/>
+                                  </p:stCondLst>
+                                  <p:childTnLst>
+                                    <p:set>
+                                      <p:cBhvr>
+                                        <p:cTn id="26" dur="1" fill="hold">
+                                          <p:stCondLst>
+                                            <p:cond delay="0"/>
+                                          </p:stCondLst>
+                                        </p:cTn>
+                                        <p:tgtEl>
+                                          <p:spTgt spid="9">
+                                            <p:txEl>
+                                              <p:pRg st="6" end="6"/>
+                                            </p:txEl>
+                                          </p:spTgt>
+                                        </p:tgtEl>
+                                        <p:attrNameLst>
+                                          <p:attrName>style.visibility</p:attrName>
+                                        </p:attrNameLst>
+                                      </p:cBhvr>
+                                      <p:to>
+                                        <p:strVal val="visible"/>
+                                      </p:to>
+                                    </p:set>
+                                  </p:childTnLst>
+                                </p:cTn>
+                              </p:par>
+                            </p:childTnLst>
+                          </p:cTn>
+                        </p:par>
+                      </p:childTnLst>
+                    </p:cTn>
+                  </p:par>
+                  <p:par>
+                    <p:cTn id="27" fill="hold">
+                      <p:stCondLst>
+                        <p:cond delay="indefinite"/>
+                      </p:stCondLst>
+                      <p:childTnLst>
+                        <p:par>
+                          <p:cTn id="28" fill="hold">
+                            <p:stCondLst>
+                              <p:cond delay="0"/>
+                            </p:stCondLst>
+                            <p:childTnLst>
+                              <p:par>
+                                <p:cTn id="29" presetID="1" presetClass="entr" presetSubtype="0" fill="hold" nodeType="clickEffect">
+                                  <p:stCondLst>
+                                    <p:cond delay="0"/>
+                                  </p:stCondLst>
+                                  <p:childTnLst>
+                                    <p:set>
+                                      <p:cBhvr>
+                                        <p:cTn id="30" dur="1" fill="hold">
+                                          <p:stCondLst>
+                                            <p:cond delay="0"/>
+                                          </p:stCondLst>
+                                        </p:cTn>
+                                        <p:tgtEl>
+                                          <p:spTgt spid="38"/>
+                                        </p:tgtEl>
+                                        <p:attrNameLst>
+                                          <p:attrName>style.visibility</p:attrName>
+                                        </p:attrNameLst>
+                                      </p:cBhvr>
+                                      <p:to>
+                                        <p:strVal val="visible"/>
+                                      </p:to>
+                                    </p:set>
+                                  </p:childTnLst>
+                                </p:cTn>
+                              </p:par>
+                              <p:par>
+                                <p:cTn id="31" presetID="1" presetClass="entr" presetSubtype="0" fill="hold" grpId="0" nodeType="withEffect">
+                                  <p:stCondLst>
+                                    <p:cond delay="0"/>
+                                  </p:stCondLst>
+                                  <p:childTnLst>
+                                    <p:set>
+                                      <p:cBhvr>
+                                        <p:cTn id="32" dur="1" fill="hold">
+                                          <p:stCondLst>
+                                            <p:cond delay="0"/>
+                                          </p:stCondLst>
+                                        </p:cTn>
+                                        <p:tgtEl>
+                                          <p:spTgt spid="36"/>
+                                        </p:tgtEl>
+                                        <p:attrNameLst>
+                                          <p:attrName>style.visibility</p:attrName>
+                                        </p:attrNameLst>
+                                      </p:cBhvr>
+                                      <p:to>
+                                        <p:strVal val="visible"/>
+                                      </p:to>
+                                    </p:set>
+                                  </p:childTnLst>
+                                </p:cTn>
+                              </p:par>
+                              <p:par>
+                                <p:cTn id="33" presetID="1" presetClass="entr" presetSubtype="0" fill="hold" nodeType="withEffect">
+                                  <p:stCondLst>
+                                    <p:cond delay="0"/>
+                                  </p:stCondLst>
+                                  <p:childTnLst>
+                                    <p:set>
+                                      <p:cBhvr>
+                                        <p:cTn id="34" dur="1" fill="hold">
+                                          <p:stCondLst>
+                                            <p:cond delay="0"/>
+                                          </p:stCondLst>
+                                        </p:cTn>
+                                        <p:tgtEl>
+                                          <p:spTgt spid="27"/>
+                                        </p:tgtEl>
+                                        <p:attrNameLst>
+                                          <p:attrName>style.visibility</p:attrName>
+                                        </p:attrNameLst>
+                                      </p:cBhvr>
+                                      <p:to>
+                                        <p:strVal val="visible"/>
+                                      </p:to>
+                                    </p:set>
+                                  </p:childTnLst>
+                                </p:cTn>
+                              </p:par>
+                              <p:par>
+                                <p:cTn id="35" presetID="1" presetClass="entr" presetSubtype="0" fill="hold" grpId="0" nodeType="withEffect">
+                                  <p:stCondLst>
+                                    <p:cond delay="0"/>
+                                  </p:stCondLst>
+                                  <p:childTnLst>
+                                    <p:set>
+                                      <p:cBhvr>
+                                        <p:cTn id="36" dur="1" fill="hold">
+                                          <p:stCondLst>
+                                            <p:cond delay="0"/>
+                                          </p:stCondLst>
+                                        </p:cTn>
+                                        <p:tgtEl>
+                                          <p:spTgt spid="39"/>
+                                        </p:tgtEl>
+                                        <p:attrNameLst>
+                                          <p:attrName>style.visibility</p:attrName>
+                                        </p:attrNameLst>
+                                      </p:cBhvr>
+                                      <p:to>
+                                        <p:strVal val="visible"/>
+                                      </p:to>
+                                    </p:set>
+                                  </p:childTnLst>
+                                </p:cTn>
+                              </p:par>
+                              <p:par>
+                                <p:cTn id="37" presetID="1" presetClass="entr" presetSubtype="0" fill="hold" grpId="0" nodeType="withEffect">
+                                  <p:stCondLst>
+                                    <p:cond delay="0"/>
+                                  </p:stCondLst>
+                                  <p:childTnLst>
+                                    <p:set>
+                                      <p:cBhvr>
+                                        <p:cTn id="38" dur="1" fill="hold">
+                                          <p:stCondLst>
+                                            <p:cond delay="0"/>
+                                          </p:stCondLst>
+                                        </p:cTn>
+                                        <p:tgtEl>
+                                          <p:spTgt spid="34"/>
+                                        </p:tgtEl>
+                                        <p:attrNameLst>
+                                          <p:attrName>style.visibility</p:attrName>
+                                        </p:attrNameLst>
+                                      </p:cBhvr>
+                                      <p:to>
+                                        <p:strVal val="visible"/>
+                                      </p:to>
+                                    </p:set>
+                                  </p:childTnLst>
+                                </p:cTn>
+                              </p:par>
+                              <p:par>
+                                <p:cTn id="39" presetID="1" presetClass="entr" presetSubtype="0" fill="hold" nodeType="withEffect">
+                                  <p:stCondLst>
+                                    <p:cond delay="0"/>
+                                  </p:stCondLst>
+                                  <p:childTnLst>
+                                    <p:set>
+                                      <p:cBhvr>
+                                        <p:cTn id="40" dur="1" fill="hold">
+                                          <p:stCondLst>
+                                            <p:cond delay="0"/>
+                                          </p:stCondLst>
+                                        </p:cTn>
+                                        <p:tgtEl>
+                                          <p:spTgt spid="29"/>
+                                        </p:tgtEl>
+                                        <p:attrNameLst>
+                                          <p:attrName>style.visibility</p:attrName>
+                                        </p:attrNameLst>
+                                      </p:cBhvr>
+                                      <p:to>
+                                        <p:strVal val="visible"/>
+                                      </p:to>
+                                    </p:set>
+                                  </p:childTnLst>
+                                </p:cTn>
+                              </p:par>
+                            </p:childTnLst>
+                          </p:cTn>
+                        </p:par>
+                      </p:childTnLst>
+                    </p:cTn>
+                  </p:par>
+                  <p:par>
+                    <p:cTn id="41" fill="hold">
+                      <p:stCondLst>
+                        <p:cond delay="indefinite"/>
+                      </p:stCondLst>
+                      <p:childTnLst>
+                        <p:par>
+                          <p:cTn id="42" fill="hold">
+                            <p:stCondLst>
+                              <p:cond delay="0"/>
+                            </p:stCondLst>
+                            <p:childTnLst>
+                              <p:par>
+                                <p:cTn id="43" presetID="1" presetClass="entr" presetSubtype="0" fill="hold" grpId="0" nodeType="clickEffect">
+                                  <p:stCondLst>
+                                    <p:cond delay="0"/>
+                                  </p:stCondLst>
+                                  <p:childTnLst>
+                                    <p:set>
+                                      <p:cBhvr>
+                                        <p:cTn id="44" dur="1" fill="hold">
+                                          <p:stCondLst>
+                                            <p:cond delay="0"/>
+                                          </p:stCondLst>
+                                        </p:cTn>
+                                        <p:tgtEl>
+                                          <p:spTgt spid="46"/>
+                                        </p:tgtEl>
+                                        <p:attrNameLst>
+                                          <p:attrName>style.visibility</p:attrName>
+                                        </p:attrNameLst>
+                                      </p:cBhvr>
+                                      <p:to>
+                                        <p:strVal val="visible"/>
+                                      </p:to>
+                                    </p:set>
+                                  </p:childTnLst>
+                                </p:cTn>
+                              </p:par>
+                              <p:par>
+                                <p:cTn id="45" presetID="1" presetClass="entr" presetSubtype="0" fill="hold" nodeType="withEffect">
+                                  <p:stCondLst>
+                                    <p:cond delay="0"/>
+                                  </p:stCondLst>
+                                  <p:childTnLst>
+                                    <p:set>
+                                      <p:cBhvr>
+                                        <p:cTn id="46" dur="1" fill="hold">
+                                          <p:stCondLst>
+                                            <p:cond delay="0"/>
+                                          </p:stCondLst>
+                                        </p:cTn>
+                                        <p:tgtEl>
+                                          <p:spTgt spid="23"/>
+                                        </p:tgtEl>
+                                        <p:attrNameLst>
+                                          <p:attrName>style.visibility</p:attrName>
+                                        </p:attrNameLst>
+                                      </p:cBhvr>
+                                      <p:to>
+                                        <p:strVal val="visible"/>
+                                      </p:to>
+                                    </p:set>
+                                  </p:childTnLst>
+                                </p:cTn>
+                              </p:par>
+                            </p:childTnLst>
+                          </p:cTn>
+                        </p:par>
+                      </p:childTnLst>
+                    </p:cTn>
+                  </p:par>
+                </p:childTnLst>
+              </p:cTn>
+              <p:prevCondLst>
+                <p:cond evt="onPrev" delay="0">
+                  <p:tgtEl>
+                    <p:sldTgt/>
+                  </p:tgtEl>
+                </p:cond>
+              </p:prevCondLst>
+              <p:nextCondLst>
+                <p:cond evt="onNext" delay="0">
+                  <p:tgtEl>
+                    <p:sldTgt/>
+                  </p:tgtEl>
+                </p:cond>
+              </p:nextCondLst>
+            </p:seq>
+          </p:childTnLst>
+        </p:cTn>
+      </p:par>
+    </p:tnLst>
+    <p:bldLst>
+      <p:bldP spid="9" grpId="0" uiExpand="1" build="p"/>
+      <p:bldP spid="34" grpId="0" animBg="1"/>
+      <p:bldP spid="36" grpId="0" animBg="1"/>
+      <p:bldP spid="39" grpId="0" animBg="1"/>
+      <p:bldP spid="46" grpId="0"/>
+    </p:bldLst>
+  </p:timing>
 </p:sld>
 </file>
 
@@ -15304,8 +17428,8 @@
           </a:prstGeom>
         </p:spPr>
       </p:pic>
-      <mc:AlternateContent xmlns:mc="http://schemas.openxmlformats.org/markup-compatibility/2006">
-        <mc:Choice xmlns:a14="http://schemas.microsoft.com/office/drawing/2010/main" Requires="a14">
+      <mc:AlternateContent xmlns:mc="http://schemas.openxmlformats.org/markup-compatibility/2006" xmlns:a14="http://schemas.microsoft.com/office/drawing/2010/main">
+        <mc:Choice Requires="a14">
           <p:sp>
             <p:nvSpPr>
               <p:cNvPr id="47" name="TextBox 46">
@@ -15334,6 +17458,7 @@
               </a:bodyPr>
               <a:lstStyle/>
               <a:p>
+                <a:pPr/>
                 <a14:m>
                   <m:oMathPara xmlns:m="http://schemas.openxmlformats.org/officeDocument/2006/math">
                     <m:oMathParaPr>
@@ -15393,7 +17518,7 @@
                           <m:nor/>
                         </m:rPr>
                         <a:rPr lang="fr-FR" b="0" i="0" smtClean="0"/>
-                        <m:t>* </m:t>
+                        <m:t>∗ </m:t>
                       </m:r>
                       <m:r>
                         <m:rPr>
@@ -15608,7 +17733,7 @@
             </p:txBody>
           </p:sp>
         </mc:Choice>
-        <mc:Fallback>
+        <mc:Fallback xmlns="">
           <p:sp>
             <p:nvSpPr>
               <p:cNvPr id="47" name="TextBox 46">

</xml_diff>